<commit_message>
Rewrite site copy for new teachers, thumbnails, link previews, footer icons off
</commit_message>
<xml_diff>
--- a/pastoral-projects/the-planting-project/downloads/The_Planting_Project.pptx
+++ b/pastoral-projects/the-planting-project/downloads/The_Planting_Project.pptx
@@ -4381,55 +4381,7 @@
                 <a:cs typeface="Calibri"/>
                 <a:sym typeface="Calibri"/>
               </a:rPr>
-              <a:t>Ten pairs. Ten herbs. A few weeks of growing and caring</a:t>
-            </a:r>
-            <a:r>
-              <a:rPr lang="en-US" sz="1600">
-                <a:solidFill>
-                  <a:srgbClr val="5C6552"/>
-                </a:solidFill>
-                <a:latin typeface="Calibri"/>
-                <a:ea typeface="Calibri"/>
-                <a:cs typeface="Calibri"/>
-                <a:sym typeface="Calibri"/>
-              </a:rPr>
-              <a:t>,</a:t>
-            </a:r>
-            <a:r>
-              <a:rPr b="0" i="0" lang="en-US" sz="1600" u="none" cap="none" strike="noStrike">
-                <a:solidFill>
-                  <a:srgbClr val="5C6552"/>
-                </a:solidFill>
-                <a:latin typeface="Calibri"/>
-                <a:ea typeface="Calibri"/>
-                <a:cs typeface="Calibri"/>
-                <a:sym typeface="Calibri"/>
-              </a:rPr>
-              <a:t> then a meal </a:t>
-            </a:r>
-            <a:r>
-              <a:rPr lang="en-US" sz="1600">
-                <a:solidFill>
-                  <a:srgbClr val="5C6552"/>
-                </a:solidFill>
-                <a:latin typeface="Calibri"/>
-                <a:ea typeface="Calibri"/>
-                <a:cs typeface="Calibri"/>
-                <a:sym typeface="Calibri"/>
-              </a:rPr>
-              <a:t>you cook for your </a:t>
-            </a:r>
-            <a:r>
-              <a:rPr lang="en-US" sz="1600">
-                <a:solidFill>
-                  <a:srgbClr val="5C6552"/>
-                </a:solidFill>
-                <a:latin typeface="Calibri"/>
-                <a:ea typeface="Calibri"/>
-                <a:cs typeface="Calibri"/>
-                <a:sym typeface="Calibri"/>
-              </a:rPr>
-              <a:t>families.</a:t>
+              <a:t>Ten pairs and ten herbs: a few weeks of growing and caring, then a meal you cook for your families.</a:t>
             </a:r>
             <a:endParaRPr b="0" i="0" sz="1600" u="none" cap="none" strike="noStrike">
               <a:solidFill>
@@ -8059,7 +8011,7 @@
                 <a:cs typeface="Calibri"/>
                 <a:sym typeface="Calibri"/>
               </a:rPr>
-              <a:t>Take a photo each week and build a gallery of your herb’s journey from seed to harvest!</a:t>
+              <a:t>Take a photo each week and build a gallery of your herb from seed to harvest!</a:t>
             </a:r>
             <a:endParaRPr b="0" i="0" sz="1300" u="none" cap="none" strike="noStrike">
               <a:solidFill>
@@ -12012,7 +11964,7 @@
                 <a:cs typeface="Calibri"/>
                 <a:sym typeface="Calibri"/>
               </a:rPr>
-              <a:t>Each pair will follow the same journey with their own herb:</a:t>
+              <a:t>Each pair will follow the same steps with their own herb:</a:t>
             </a:r>
             <a:endParaRPr b="0" i="0" sz="1300" u="none" cap="none" strike="noStrike">
               <a:solidFill>

</xml_diff>